<commit_message>
Use faded scene images for AI technology rows in theme park cases slide
Co-Authored-By: Claude Opus 5.5 <noreply@anthropic.com>
Claude-Session: https://claude.ai/code/session_014TbtPTXZRwab3hp8YY9eJi
</commit_message>
<xml_diff>
--- a/02_Themepark_AI_Cases.pptx
+++ b/02_Themepark_AI_Cases.pptx
@@ -3235,55 +3235,9 @@
           </a:p>
         </p:txBody>
       </p:sp>
-      <p:sp>
-        <p:nvSpPr>
-          <p:cNvPr id="6" name="Oval 5"/>
-          <p:cNvSpPr/>
-          <p:nvPr/>
-        </p:nvSpPr>
-        <p:spPr>
-          <a:xfrm>
-            <a:off x="548640" y="2029968"/>
-            <a:ext cx="777240" cy="777240"/>
-          </a:xfrm>
-          <a:prstGeom prst="ellipse">
-            <a:avLst/>
-          </a:prstGeom>
-          <a:solidFill>
-            <a:srgbClr val="FFFFFF"/>
-          </a:solidFill>
-          <a:ln w="38100">
-            <a:solidFill>
-              <a:srgbClr val="FFE600"/>
-            </a:solidFill>
-          </a:ln>
-          <a:effectLst/>
-        </p:spPr>
-        <p:style>
-          <a:lnRef idx="1">
-            <a:schemeClr val="accent1"/>
-          </a:lnRef>
-          <a:fillRef idx="3">
-            <a:schemeClr val="accent1"/>
-          </a:fillRef>
-          <a:effectRef idx="2">
-            <a:schemeClr val="accent1"/>
-          </a:effectRef>
-          <a:fontRef idx="minor">
-            <a:schemeClr val="lt1"/>
-          </a:fontRef>
-        </p:style>
-        <p:txBody>
-          <a:bodyPr rtlCol="0" anchor="ctr"/>
-          <a:lstStyle/>
-          <a:p>
-            <a:pPr algn="ctr"/>
-          </a:p>
-        </p:txBody>
-      </p:sp>
       <p:pic>
         <p:nvPicPr>
-          <p:cNvPr id="7" name="Picture 6" descr="ic_chart.png"/>
+          <p:cNvPr id="6" name="Picture 5" descr="bg_predict.jpg"/>
           <p:cNvPicPr>
             <a:picLocks noChangeAspect="1"/>
           </p:cNvPicPr>
@@ -3297,8 +3251,8 @@
         </p:blipFill>
         <p:spPr>
           <a:xfrm>
-            <a:off x="740664" y="2221992"/>
-            <a:ext cx="393192" cy="393192"/>
+            <a:off x="365760" y="1874519"/>
+            <a:ext cx="2926080" cy="1069848"/>
           </a:xfrm>
           <a:prstGeom prst="rect">
             <a:avLst/>
@@ -3307,14 +3261,14 @@
       </p:pic>
       <p:sp>
         <p:nvSpPr>
-          <p:cNvPr id="8" name="TextBox 7"/>
+          <p:cNvPr id="7" name="TextBox 6"/>
           <p:cNvSpPr txBox="1"/>
           <p:nvPr/>
         </p:nvSpPr>
         <p:spPr>
           <a:xfrm>
-            <a:off x="274320" y="2862072"/>
-            <a:ext cx="1325880" cy="411480"/>
+            <a:off x="411480" y="1984248"/>
+            <a:ext cx="1645920" cy="502920"/>
           </a:xfrm>
           <a:prstGeom prst="rect">
             <a:avLst/>
@@ -3329,7 +3283,7 @@
           <a:p>
             <a:pPr algn="ctr"/>
             <a:r>
-              <a:rPr sz="1150" b="1" i="0" u="none">
+              <a:rPr sz="1600" b="1" i="0" u="none">
                 <a:solidFill>
                   <a:srgbClr val="262626"/>
                 </a:solidFill>
@@ -3343,9 +3297,9 @@
           <a:p>
             <a:pPr algn="ctr"/>
             <a:r>
-              <a:rPr sz="1000" b="0" i="0" u="none">
-                <a:solidFill>
-                  <a:srgbClr val="7F7F7F"/>
+              <a:rPr sz="1050" b="1" i="0" u="none">
+                <a:solidFill>
+                  <a:srgbClr val="404040"/>
                 </a:solidFill>
                 <a:latin typeface="맑은 고딕"/>
                 <a:ea typeface="맑은 고딕"/>
@@ -3358,14 +3312,102 @@
       </p:sp>
       <p:sp>
         <p:nvSpPr>
-          <p:cNvPr id="9" name="Rectangle 8"/>
+          <p:cNvPr id="8" name="Chevron 7"/>
           <p:cNvSpPr/>
           <p:nvPr/>
         </p:nvSpPr>
         <p:spPr>
-          <a:xfrm>
-            <a:off x="1691640" y="2103120"/>
-            <a:ext cx="82296" cy="82296"/>
+          <a:xfrm rot="5400000">
+            <a:off x="1143000" y="2496312"/>
+            <a:ext cx="128016" cy="182880"/>
+          </a:xfrm>
+          <a:prstGeom prst="chevron">
+            <a:avLst/>
+          </a:prstGeom>
+          <a:solidFill>
+            <a:srgbClr val="1F3864"/>
+          </a:solidFill>
+          <a:ln>
+            <a:noFill/>
+          </a:ln>
+          <a:effectLst/>
+        </p:spPr>
+        <p:style>
+          <a:lnRef idx="1">
+            <a:schemeClr val="accent1"/>
+          </a:lnRef>
+          <a:fillRef idx="3">
+            <a:schemeClr val="accent1"/>
+          </a:fillRef>
+          <a:effectRef idx="2">
+            <a:schemeClr val="accent1"/>
+          </a:effectRef>
+          <a:fontRef idx="minor">
+            <a:schemeClr val="lt1"/>
+          </a:fontRef>
+        </p:style>
+        <p:txBody>
+          <a:bodyPr rtlCol="0" anchor="ctr"/>
+          <a:lstStyle/>
+          <a:p>
+            <a:pPr algn="ctr"/>
+          </a:p>
+        </p:txBody>
+      </p:sp>
+      <p:sp>
+        <p:nvSpPr>
+          <p:cNvPr id="9" name="Chevron 8"/>
+          <p:cNvSpPr/>
+          <p:nvPr/>
+        </p:nvSpPr>
+        <p:spPr>
+          <a:xfrm rot="5400000">
+            <a:off x="1143000" y="2587752"/>
+            <a:ext cx="128016" cy="182880"/>
+          </a:xfrm>
+          <a:prstGeom prst="chevron">
+            <a:avLst/>
+          </a:prstGeom>
+          <a:solidFill>
+            <a:srgbClr val="1F3864"/>
+          </a:solidFill>
+          <a:ln>
+            <a:noFill/>
+          </a:ln>
+          <a:effectLst/>
+        </p:spPr>
+        <p:style>
+          <a:lnRef idx="1">
+            <a:schemeClr val="accent1"/>
+          </a:lnRef>
+          <a:fillRef idx="3">
+            <a:schemeClr val="accent1"/>
+          </a:fillRef>
+          <a:effectRef idx="2">
+            <a:schemeClr val="accent1"/>
+          </a:effectRef>
+          <a:fontRef idx="minor">
+            <a:schemeClr val="lt1"/>
+          </a:fontRef>
+        </p:style>
+        <p:txBody>
+          <a:bodyPr rtlCol="0" anchor="ctr"/>
+          <a:lstStyle/>
+          <a:p>
+            <a:pPr algn="ctr"/>
+          </a:p>
+        </p:txBody>
+      </p:sp>
+      <p:sp>
+        <p:nvSpPr>
+          <p:cNvPr id="10" name="Rectangle 9"/>
+          <p:cNvSpPr/>
+          <p:nvPr/>
+        </p:nvSpPr>
+        <p:spPr>
+          <a:xfrm>
+            <a:off x="2103120" y="2029967"/>
+            <a:ext cx="73152" cy="73152"/>
           </a:xfrm>
           <a:prstGeom prst="rect">
             <a:avLst/>
@@ -3402,14 +3444,14 @@
       </p:sp>
       <p:sp>
         <p:nvSpPr>
-          <p:cNvPr id="10" name="TextBox 9"/>
+          <p:cNvPr id="11" name="TextBox 10"/>
           <p:cNvSpPr txBox="1"/>
           <p:nvPr/>
         </p:nvSpPr>
         <p:spPr>
           <a:xfrm>
-            <a:off x="1874519" y="2029968"/>
-            <a:ext cx="3977639" cy="594360"/>
+            <a:off x="2240280" y="1965960"/>
+            <a:ext cx="3611880" cy="457200"/>
           </a:xfrm>
           <a:prstGeom prst="rect">
             <a:avLst/>
@@ -3424,7 +3466,7 @@
           <a:p>
             <a:pPr algn="l"/>
             <a:r>
-              <a:rPr sz="1150" b="0" i="0" u="none">
+              <a:rPr sz="1100" b="1" i="0" u="none">
                 <a:solidFill>
                   <a:srgbClr val="262626"/>
                 </a:solidFill>
@@ -3438,7 +3480,7 @@
           <a:p>
             <a:pPr algn="l"/>
             <a:r>
-              <a:rPr sz="1050" b="0" i="0" u="none">
+              <a:rPr sz="1000" b="0" i="0" u="none">
                 <a:solidFill>
                   <a:srgbClr val="595959"/>
                 </a:solidFill>
@@ -3453,14 +3495,14 @@
       </p:sp>
       <p:sp>
         <p:nvSpPr>
-          <p:cNvPr id="11" name="Rectangle 10"/>
+          <p:cNvPr id="12" name="Rectangle 11"/>
           <p:cNvSpPr/>
           <p:nvPr/>
         </p:nvSpPr>
         <p:spPr>
           <a:xfrm>
-            <a:off x="1691640" y="2761488"/>
-            <a:ext cx="82296" cy="82296"/>
+            <a:off x="2103120" y="2514599"/>
+            <a:ext cx="73152" cy="73152"/>
           </a:xfrm>
           <a:prstGeom prst="rect">
             <a:avLst/>
@@ -3497,14 +3539,14 @@
       </p:sp>
       <p:sp>
         <p:nvSpPr>
-          <p:cNvPr id="12" name="TextBox 11"/>
+          <p:cNvPr id="13" name="TextBox 12"/>
           <p:cNvSpPr txBox="1"/>
           <p:nvPr/>
         </p:nvSpPr>
         <p:spPr>
           <a:xfrm>
-            <a:off x="1874519" y="2688336"/>
-            <a:ext cx="3977639" cy="594360"/>
+            <a:off x="2240280" y="2450591"/>
+            <a:ext cx="3611880" cy="457200"/>
           </a:xfrm>
           <a:prstGeom prst="rect">
             <a:avLst/>
@@ -3519,7 +3561,7 @@
           <a:p>
             <a:pPr algn="l"/>
             <a:r>
-              <a:rPr sz="1150" b="0" i="0" u="none">
+              <a:rPr sz="1100" b="1" i="0" u="none">
                 <a:solidFill>
                   <a:srgbClr val="262626"/>
                 </a:solidFill>
@@ -3533,7 +3575,7 @@
           <a:p>
             <a:pPr algn="l"/>
             <a:r>
-              <a:rPr sz="1050" b="0" i="0" u="none">
+              <a:rPr sz="1000" b="0" i="0" u="none">
                 <a:solidFill>
                   <a:srgbClr val="595959"/>
                 </a:solidFill>
@@ -3546,63 +3588,25 @@
           </a:p>
         </p:txBody>
       </p:sp>
-      <p:cxnSp>
-        <p:nvCxnSpPr>
-          <p:cNvPr id="13" name="Connector 12"/>
-          <p:cNvCxnSpPr/>
-          <p:nvPr/>
-        </p:nvCxnSpPr>
-        <p:spPr>
-          <a:xfrm>
-            <a:off x="411480" y="3355848"/>
-            <a:ext cx="5394960" cy="0"/>
-          </a:xfrm>
-          <a:prstGeom prst="line">
-            <a:avLst/>
-          </a:prstGeom>
-          <a:ln w="9525">
-            <a:solidFill>
-              <a:srgbClr val="A6A6A6"/>
-            </a:solidFill>
-            <a:prstDash val="dash"/>
-          </a:ln>
-        </p:spPr>
-        <p:style>
-          <a:lnRef idx="2">
-            <a:schemeClr val="accent1"/>
-          </a:lnRef>
-          <a:fillRef idx="0">
-            <a:schemeClr val="accent1"/>
-          </a:fillRef>
-          <a:effectRef idx="1">
-            <a:schemeClr val="accent1"/>
-          </a:effectRef>
-          <a:fontRef idx="minor">
-            <a:schemeClr val="tx1"/>
-          </a:fontRef>
-        </p:style>
-      </p:cxnSp>
-      <p:sp>
-        <p:nvSpPr>
-          <p:cNvPr id="14" name="Oval 13"/>
+      <p:sp>
+        <p:nvSpPr>
+          <p:cNvPr id="14" name="Rectangle 13"/>
           <p:cNvSpPr/>
           <p:nvPr/>
         </p:nvSpPr>
         <p:spPr>
           <a:xfrm>
-            <a:off x="548640" y="3538728"/>
-            <a:ext cx="777240" cy="777240"/>
-          </a:xfrm>
-          <a:prstGeom prst="ellipse">
+            <a:off x="365760" y="2971800"/>
+            <a:ext cx="5486400" cy="329184"/>
+          </a:xfrm>
+          <a:prstGeom prst="rect">
             <a:avLst/>
           </a:prstGeom>
           <a:solidFill>
-            <a:srgbClr val="FFFFFF"/>
+            <a:srgbClr val="404040"/>
           </a:solidFill>
-          <a:ln w="38100">
-            <a:solidFill>
-              <a:srgbClr val="FFE600"/>
-            </a:solidFill>
+          <a:ln>
+            <a:noFill/>
           </a:ln>
           <a:effectLst/>
         </p:spPr>
@@ -3621,16 +3625,27 @@
           </a:fontRef>
         </p:style>
         <p:txBody>
-          <a:bodyPr rtlCol="0" anchor="ctr"/>
+          <a:bodyPr rtlCol="0" anchor="ctr" wrap="square" lIns="18288" rIns="18288" tIns="18288" bIns="18288"/>
           <a:lstStyle/>
           <a:p>
             <a:pPr algn="ctr"/>
+            <a:r>
+              <a:rPr sz="1200" b="1" i="0" u="none">
+                <a:solidFill>
+                  <a:srgbClr val="FFFFFF"/>
+                </a:solidFill>
+                <a:latin typeface="맑은 고딕"/>
+                <a:ea typeface="맑은 고딕"/>
+                <a:cs typeface="맑은 고딕"/>
+              </a:rPr>
+              <a:t>데이터 기반 수요 예측으로 운영 효율과 수익을 동시에 최적화</a:t>
+            </a:r>
           </a:p>
         </p:txBody>
       </p:sp>
       <p:pic>
         <p:nvPicPr>
-          <p:cNvPr id="15" name="Picture 14" descr="ic_chat.png"/>
+          <p:cNvPr id="15" name="Picture 14" descr="bg_genai.jpg"/>
           <p:cNvPicPr>
             <a:picLocks noChangeAspect="1"/>
           </p:cNvPicPr>
@@ -3644,8 +3659,8 @@
         </p:blipFill>
         <p:spPr>
           <a:xfrm>
-            <a:off x="740664" y="3730752"/>
-            <a:ext cx="393192" cy="393192"/>
+            <a:off x="365760" y="3401568"/>
+            <a:ext cx="2926080" cy="1069848"/>
           </a:xfrm>
           <a:prstGeom prst="rect">
             <a:avLst/>
@@ -3660,8 +3675,8 @@
         </p:nvSpPr>
         <p:spPr>
           <a:xfrm>
-            <a:off x="274320" y="4370832"/>
-            <a:ext cx="1325880" cy="411480"/>
+            <a:off x="411480" y="3511296"/>
+            <a:ext cx="1645920" cy="502920"/>
           </a:xfrm>
           <a:prstGeom prst="rect">
             <a:avLst/>
@@ -3676,7 +3691,7 @@
           <a:p>
             <a:pPr algn="ctr"/>
             <a:r>
-              <a:rPr sz="1150" b="1" i="0" u="none">
+              <a:rPr sz="1600" b="1" i="0" u="none">
                 <a:solidFill>
                   <a:srgbClr val="262626"/>
                 </a:solidFill>
@@ -3690,9 +3705,9 @@
           <a:p>
             <a:pPr algn="ctr"/>
             <a:r>
-              <a:rPr sz="1000" b="0" i="0" u="none">
-                <a:solidFill>
-                  <a:srgbClr val="7F7F7F"/>
+              <a:rPr sz="1050" b="1" i="0" u="none">
+                <a:solidFill>
+                  <a:srgbClr val="404040"/>
                 </a:solidFill>
                 <a:latin typeface="맑은 고딕"/>
                 <a:ea typeface="맑은 고딕"/>
@@ -3705,14 +3720,102 @@
       </p:sp>
       <p:sp>
         <p:nvSpPr>
-          <p:cNvPr id="17" name="Rectangle 16"/>
+          <p:cNvPr id="17" name="Chevron 16"/>
           <p:cNvSpPr/>
           <p:nvPr/>
         </p:nvSpPr>
         <p:spPr>
-          <a:xfrm>
-            <a:off x="1691640" y="3611880"/>
-            <a:ext cx="82296" cy="82296"/>
+          <a:xfrm rot="5400000">
+            <a:off x="1143000" y="4023359"/>
+            <a:ext cx="128016" cy="182880"/>
+          </a:xfrm>
+          <a:prstGeom prst="chevron">
+            <a:avLst/>
+          </a:prstGeom>
+          <a:solidFill>
+            <a:srgbClr val="1F3864"/>
+          </a:solidFill>
+          <a:ln>
+            <a:noFill/>
+          </a:ln>
+          <a:effectLst/>
+        </p:spPr>
+        <p:style>
+          <a:lnRef idx="1">
+            <a:schemeClr val="accent1"/>
+          </a:lnRef>
+          <a:fillRef idx="3">
+            <a:schemeClr val="accent1"/>
+          </a:fillRef>
+          <a:effectRef idx="2">
+            <a:schemeClr val="accent1"/>
+          </a:effectRef>
+          <a:fontRef idx="minor">
+            <a:schemeClr val="lt1"/>
+          </a:fontRef>
+        </p:style>
+        <p:txBody>
+          <a:bodyPr rtlCol="0" anchor="ctr"/>
+          <a:lstStyle/>
+          <a:p>
+            <a:pPr algn="ctr"/>
+          </a:p>
+        </p:txBody>
+      </p:sp>
+      <p:sp>
+        <p:nvSpPr>
+          <p:cNvPr id="18" name="Chevron 17"/>
+          <p:cNvSpPr/>
+          <p:nvPr/>
+        </p:nvSpPr>
+        <p:spPr>
+          <a:xfrm rot="5400000">
+            <a:off x="1143000" y="4114799"/>
+            <a:ext cx="128016" cy="182880"/>
+          </a:xfrm>
+          <a:prstGeom prst="chevron">
+            <a:avLst/>
+          </a:prstGeom>
+          <a:solidFill>
+            <a:srgbClr val="1F3864"/>
+          </a:solidFill>
+          <a:ln>
+            <a:noFill/>
+          </a:ln>
+          <a:effectLst/>
+        </p:spPr>
+        <p:style>
+          <a:lnRef idx="1">
+            <a:schemeClr val="accent1"/>
+          </a:lnRef>
+          <a:fillRef idx="3">
+            <a:schemeClr val="accent1"/>
+          </a:fillRef>
+          <a:effectRef idx="2">
+            <a:schemeClr val="accent1"/>
+          </a:effectRef>
+          <a:fontRef idx="minor">
+            <a:schemeClr val="lt1"/>
+          </a:fontRef>
+        </p:style>
+        <p:txBody>
+          <a:bodyPr rtlCol="0" anchor="ctr"/>
+          <a:lstStyle/>
+          <a:p>
+            <a:pPr algn="ctr"/>
+          </a:p>
+        </p:txBody>
+      </p:sp>
+      <p:sp>
+        <p:nvSpPr>
+          <p:cNvPr id="19" name="Rectangle 18"/>
+          <p:cNvSpPr/>
+          <p:nvPr/>
+        </p:nvSpPr>
+        <p:spPr>
+          <a:xfrm>
+            <a:off x="2103120" y="3557015"/>
+            <a:ext cx="73152" cy="73152"/>
           </a:xfrm>
           <a:prstGeom prst="rect">
             <a:avLst/>
@@ -3749,14 +3852,14 @@
       </p:sp>
       <p:sp>
         <p:nvSpPr>
-          <p:cNvPr id="18" name="TextBox 17"/>
+          <p:cNvPr id="20" name="TextBox 19"/>
           <p:cNvSpPr txBox="1"/>
           <p:nvPr/>
         </p:nvSpPr>
         <p:spPr>
           <a:xfrm>
-            <a:off x="1874519" y="3538728"/>
-            <a:ext cx="3977639" cy="594360"/>
+            <a:off x="2240280" y="3493008"/>
+            <a:ext cx="3611880" cy="457200"/>
           </a:xfrm>
           <a:prstGeom prst="rect">
             <a:avLst/>
@@ -3771,7 +3874,7 @@
           <a:p>
             <a:pPr algn="l"/>
             <a:r>
-              <a:rPr sz="1150" b="0" i="0" u="none">
+              <a:rPr sz="1100" b="1" i="0" u="none">
                 <a:solidFill>
                   <a:srgbClr val="262626"/>
                 </a:solidFill>
@@ -3785,7 +3888,7 @@
           <a:p>
             <a:pPr algn="l"/>
             <a:r>
-              <a:rPr sz="1050" b="0" i="0" u="none">
+              <a:rPr sz="1000" b="0" i="0" u="none">
                 <a:solidFill>
                   <a:srgbClr val="595959"/>
                 </a:solidFill>
@@ -3800,14 +3903,14 @@
       </p:sp>
       <p:sp>
         <p:nvSpPr>
-          <p:cNvPr id="19" name="Rectangle 18"/>
+          <p:cNvPr id="21" name="Rectangle 20"/>
           <p:cNvSpPr/>
           <p:nvPr/>
         </p:nvSpPr>
         <p:spPr>
           <a:xfrm>
-            <a:off x="1691640" y="4270248"/>
-            <a:ext cx="82296" cy="82296"/>
+            <a:off x="2103120" y="4041648"/>
+            <a:ext cx="73152" cy="73152"/>
           </a:xfrm>
           <a:prstGeom prst="rect">
             <a:avLst/>
@@ -3844,14 +3947,14 @@
       </p:sp>
       <p:sp>
         <p:nvSpPr>
-          <p:cNvPr id="20" name="TextBox 19"/>
+          <p:cNvPr id="22" name="TextBox 21"/>
           <p:cNvSpPr txBox="1"/>
           <p:nvPr/>
         </p:nvSpPr>
         <p:spPr>
           <a:xfrm>
-            <a:off x="1874519" y="4197096"/>
-            <a:ext cx="3977639" cy="594360"/>
+            <a:off x="2240280" y="3977639"/>
+            <a:ext cx="3611880" cy="457200"/>
           </a:xfrm>
           <a:prstGeom prst="rect">
             <a:avLst/>
@@ -3866,7 +3969,7 @@
           <a:p>
             <a:pPr algn="l"/>
             <a:r>
-              <a:rPr sz="1150" b="0" i="0" u="none">
+              <a:rPr sz="1100" b="1" i="0" u="none">
                 <a:solidFill>
                   <a:srgbClr val="262626"/>
                 </a:solidFill>
@@ -3880,7 +3983,7 @@
           <a:p>
             <a:pPr algn="l"/>
             <a:r>
-              <a:rPr sz="1050" b="0" i="0" u="none">
+              <a:rPr sz="1000" b="0" i="0" u="none">
                 <a:solidFill>
                   <a:srgbClr val="595959"/>
                 </a:solidFill>
@@ -3893,63 +3996,25 @@
           </a:p>
         </p:txBody>
       </p:sp>
-      <p:cxnSp>
-        <p:nvCxnSpPr>
-          <p:cNvPr id="21" name="Connector 20"/>
-          <p:cNvCxnSpPr/>
-          <p:nvPr/>
-        </p:nvCxnSpPr>
-        <p:spPr>
-          <a:xfrm>
-            <a:off x="411480" y="4864608"/>
-            <a:ext cx="5394960" cy="0"/>
-          </a:xfrm>
-          <a:prstGeom prst="line">
-            <a:avLst/>
-          </a:prstGeom>
-          <a:ln w="9525">
-            <a:solidFill>
-              <a:srgbClr val="A6A6A6"/>
-            </a:solidFill>
-            <a:prstDash val="dash"/>
-          </a:ln>
-        </p:spPr>
-        <p:style>
-          <a:lnRef idx="2">
-            <a:schemeClr val="accent1"/>
-          </a:lnRef>
-          <a:fillRef idx="0">
-            <a:schemeClr val="accent1"/>
-          </a:fillRef>
-          <a:effectRef idx="1">
-            <a:schemeClr val="accent1"/>
-          </a:effectRef>
-          <a:fontRef idx="minor">
-            <a:schemeClr val="tx1"/>
-          </a:fontRef>
-        </p:style>
-      </p:cxnSp>
-      <p:sp>
-        <p:nvSpPr>
-          <p:cNvPr id="22" name="Oval 21"/>
+      <p:sp>
+        <p:nvSpPr>
+          <p:cNvPr id="23" name="Rectangle 22"/>
           <p:cNvSpPr/>
           <p:nvPr/>
         </p:nvSpPr>
         <p:spPr>
           <a:xfrm>
-            <a:off x="548640" y="5047488"/>
-            <a:ext cx="777240" cy="777240"/>
-          </a:xfrm>
-          <a:prstGeom prst="ellipse">
+            <a:off x="365760" y="4498848"/>
+            <a:ext cx="5486400" cy="329184"/>
+          </a:xfrm>
+          <a:prstGeom prst="rect">
             <a:avLst/>
           </a:prstGeom>
           <a:solidFill>
-            <a:srgbClr val="FFFFFF"/>
+            <a:srgbClr val="404040"/>
           </a:solidFill>
-          <a:ln w="38100">
-            <a:solidFill>
-              <a:srgbClr val="FFE600"/>
-            </a:solidFill>
+          <a:ln>
+            <a:noFill/>
           </a:ln>
           <a:effectLst/>
         </p:spPr>
@@ -3968,16 +4033,27 @@
           </a:fontRef>
         </p:style>
         <p:txBody>
-          <a:bodyPr rtlCol="0" anchor="ctr"/>
+          <a:bodyPr rtlCol="0" anchor="ctr" wrap="square" lIns="18288" rIns="18288" tIns="18288" bIns="18288"/>
           <a:lstStyle/>
           <a:p>
             <a:pPr algn="ctr"/>
+            <a:r>
+              <a:rPr sz="1200" b="1" i="0" u="none">
+                <a:solidFill>
+                  <a:srgbClr val="FFFFFF"/>
+                </a:solidFill>
+                <a:latin typeface="맑은 고딕"/>
+                <a:ea typeface="맑은 고딕"/>
+                <a:cs typeface="맑은 고딕"/>
+              </a:rPr>
+              <a:t>고객 한 명 한 명에게 맞춘 일정·콘텐츠로 경험 가치 제고</a:t>
+            </a:r>
           </a:p>
         </p:txBody>
       </p:sp>
       <p:pic>
         <p:nvPicPr>
-          <p:cNvPr id="23" name="Picture 22" descr="ic_bot.png"/>
+          <p:cNvPr id="24" name="Picture 23" descr="bg_vision.jpg"/>
           <p:cNvPicPr>
             <a:picLocks noChangeAspect="1"/>
           </p:cNvPicPr>
@@ -3991,8 +4067,8 @@
         </p:blipFill>
         <p:spPr>
           <a:xfrm>
-            <a:off x="740664" y="5239512"/>
-            <a:ext cx="393192" cy="393192"/>
+            <a:off x="365760" y="4928616"/>
+            <a:ext cx="2926080" cy="1069848"/>
           </a:xfrm>
           <a:prstGeom prst="rect">
             <a:avLst/>
@@ -4001,14 +4077,14 @@
       </p:pic>
       <p:sp>
         <p:nvSpPr>
-          <p:cNvPr id="24" name="TextBox 23"/>
+          <p:cNvPr id="25" name="TextBox 24"/>
           <p:cNvSpPr txBox="1"/>
           <p:nvPr/>
         </p:nvSpPr>
         <p:spPr>
           <a:xfrm>
-            <a:off x="274320" y="5879592"/>
-            <a:ext cx="1325880" cy="411480"/>
+            <a:off x="411480" y="5038344"/>
+            <a:ext cx="1645920" cy="502920"/>
           </a:xfrm>
           <a:prstGeom prst="rect">
             <a:avLst/>
@@ -4023,7 +4099,7 @@
           <a:p>
             <a:pPr algn="ctr"/>
             <a:r>
-              <a:rPr sz="1150" b="1" i="0" u="none">
+              <a:rPr sz="1600" b="1" i="0" u="none">
                 <a:solidFill>
                   <a:srgbClr val="262626"/>
                 </a:solidFill>
@@ -4037,9 +4113,9 @@
           <a:p>
             <a:pPr algn="ctr"/>
             <a:r>
-              <a:rPr sz="1000" b="0" i="0" u="none">
-                <a:solidFill>
-                  <a:srgbClr val="7F7F7F"/>
+              <a:rPr sz="1050" b="1" i="0" u="none">
+                <a:solidFill>
+                  <a:srgbClr val="404040"/>
                 </a:solidFill>
                 <a:latin typeface="맑은 고딕"/>
                 <a:ea typeface="맑은 고딕"/>
@@ -4052,14 +4128,102 @@
       </p:sp>
       <p:sp>
         <p:nvSpPr>
-          <p:cNvPr id="25" name="Rectangle 24"/>
+          <p:cNvPr id="26" name="Chevron 25"/>
           <p:cNvSpPr/>
           <p:nvPr/>
         </p:nvSpPr>
         <p:spPr>
-          <a:xfrm>
-            <a:off x="1691640" y="5120640"/>
-            <a:ext cx="82296" cy="82296"/>
+          <a:xfrm rot="5400000">
+            <a:off x="1143000" y="5550407"/>
+            <a:ext cx="128016" cy="182880"/>
+          </a:xfrm>
+          <a:prstGeom prst="chevron">
+            <a:avLst/>
+          </a:prstGeom>
+          <a:solidFill>
+            <a:srgbClr val="1F3864"/>
+          </a:solidFill>
+          <a:ln>
+            <a:noFill/>
+          </a:ln>
+          <a:effectLst/>
+        </p:spPr>
+        <p:style>
+          <a:lnRef idx="1">
+            <a:schemeClr val="accent1"/>
+          </a:lnRef>
+          <a:fillRef idx="3">
+            <a:schemeClr val="accent1"/>
+          </a:fillRef>
+          <a:effectRef idx="2">
+            <a:schemeClr val="accent1"/>
+          </a:effectRef>
+          <a:fontRef idx="minor">
+            <a:schemeClr val="lt1"/>
+          </a:fontRef>
+        </p:style>
+        <p:txBody>
+          <a:bodyPr rtlCol="0" anchor="ctr"/>
+          <a:lstStyle/>
+          <a:p>
+            <a:pPr algn="ctr"/>
+          </a:p>
+        </p:txBody>
+      </p:sp>
+      <p:sp>
+        <p:nvSpPr>
+          <p:cNvPr id="27" name="Chevron 26"/>
+          <p:cNvSpPr/>
+          <p:nvPr/>
+        </p:nvSpPr>
+        <p:spPr>
+          <a:xfrm rot="5400000">
+            <a:off x="1143000" y="5641847"/>
+            <a:ext cx="128016" cy="182880"/>
+          </a:xfrm>
+          <a:prstGeom prst="chevron">
+            <a:avLst/>
+          </a:prstGeom>
+          <a:solidFill>
+            <a:srgbClr val="1F3864"/>
+          </a:solidFill>
+          <a:ln>
+            <a:noFill/>
+          </a:ln>
+          <a:effectLst/>
+        </p:spPr>
+        <p:style>
+          <a:lnRef idx="1">
+            <a:schemeClr val="accent1"/>
+          </a:lnRef>
+          <a:fillRef idx="3">
+            <a:schemeClr val="accent1"/>
+          </a:fillRef>
+          <a:effectRef idx="2">
+            <a:schemeClr val="accent1"/>
+          </a:effectRef>
+          <a:fontRef idx="minor">
+            <a:schemeClr val="lt1"/>
+          </a:fontRef>
+        </p:style>
+        <p:txBody>
+          <a:bodyPr rtlCol="0" anchor="ctr"/>
+          <a:lstStyle/>
+          <a:p>
+            <a:pPr algn="ctr"/>
+          </a:p>
+        </p:txBody>
+      </p:sp>
+      <p:sp>
+        <p:nvSpPr>
+          <p:cNvPr id="28" name="Rectangle 27"/>
+          <p:cNvSpPr/>
+          <p:nvPr/>
+        </p:nvSpPr>
+        <p:spPr>
+          <a:xfrm>
+            <a:off x="2103120" y="5084064"/>
+            <a:ext cx="73152" cy="73152"/>
           </a:xfrm>
           <a:prstGeom prst="rect">
             <a:avLst/>
@@ -4096,14 +4260,14 @@
       </p:sp>
       <p:sp>
         <p:nvSpPr>
-          <p:cNvPr id="26" name="TextBox 25"/>
+          <p:cNvPr id="29" name="TextBox 28"/>
           <p:cNvSpPr txBox="1"/>
           <p:nvPr/>
         </p:nvSpPr>
         <p:spPr>
           <a:xfrm>
-            <a:off x="1874519" y="5047488"/>
-            <a:ext cx="3977639" cy="594360"/>
+            <a:off x="2240280" y="5020055"/>
+            <a:ext cx="3611880" cy="457200"/>
           </a:xfrm>
           <a:prstGeom prst="rect">
             <a:avLst/>
@@ -4118,7 +4282,7 @@
           <a:p>
             <a:pPr algn="l"/>
             <a:r>
-              <a:rPr sz="1150" b="0" i="0" u="none">
+              <a:rPr sz="1100" b="1" i="0" u="none">
                 <a:solidFill>
                   <a:srgbClr val="262626"/>
                 </a:solidFill>
@@ -4132,7 +4296,7 @@
           <a:p>
             <a:pPr algn="l"/>
             <a:r>
-              <a:rPr sz="1050" b="0" i="0" u="none">
+              <a:rPr sz="1000" b="0" i="0" u="none">
                 <a:solidFill>
                   <a:srgbClr val="595959"/>
                 </a:solidFill>
@@ -4147,14 +4311,14 @@
       </p:sp>
       <p:sp>
         <p:nvSpPr>
-          <p:cNvPr id="27" name="Rectangle 26"/>
+          <p:cNvPr id="30" name="Rectangle 29"/>
           <p:cNvSpPr/>
           <p:nvPr/>
         </p:nvSpPr>
         <p:spPr>
           <a:xfrm>
-            <a:off x="1691640" y="5779008"/>
-            <a:ext cx="82296" cy="82296"/>
+            <a:off x="2103120" y="5568696"/>
+            <a:ext cx="73152" cy="73152"/>
           </a:xfrm>
           <a:prstGeom prst="rect">
             <a:avLst/>
@@ -4191,14 +4355,14 @@
       </p:sp>
       <p:sp>
         <p:nvSpPr>
-          <p:cNvPr id="28" name="TextBox 27"/>
+          <p:cNvPr id="31" name="TextBox 30"/>
           <p:cNvSpPr txBox="1"/>
           <p:nvPr/>
         </p:nvSpPr>
         <p:spPr>
           <a:xfrm>
-            <a:off x="1874519" y="5705856"/>
-            <a:ext cx="3977639" cy="594360"/>
+            <a:off x="2240280" y="5504688"/>
+            <a:ext cx="3611880" cy="457200"/>
           </a:xfrm>
           <a:prstGeom prst="rect">
             <a:avLst/>
@@ -4213,7 +4377,7 @@
           <a:p>
             <a:pPr algn="l"/>
             <a:r>
-              <a:rPr sz="1150" b="0" i="0" u="none">
+              <a:rPr sz="1100" b="1" i="0" u="none">
                 <a:solidFill>
                   <a:srgbClr val="262626"/>
                 </a:solidFill>
@@ -4227,7 +4391,7 @@
           <a:p>
             <a:pPr algn="l"/>
             <a:r>
-              <a:rPr sz="1050" b="0" i="0" u="none">
+              <a:rPr sz="1000" b="0" i="0" u="none">
                 <a:solidFill>
                   <a:srgbClr val="595959"/>
                 </a:solidFill>
@@ -4242,7 +4406,62 @@
       </p:sp>
       <p:sp>
         <p:nvSpPr>
-          <p:cNvPr id="29" name="TextBox 28"/>
+          <p:cNvPr id="32" name="Rectangle 31"/>
+          <p:cNvSpPr/>
+          <p:nvPr/>
+        </p:nvSpPr>
+        <p:spPr>
+          <a:xfrm>
+            <a:off x="365760" y="6025896"/>
+            <a:ext cx="5486400" cy="329184"/>
+          </a:xfrm>
+          <a:prstGeom prst="rect">
+            <a:avLst/>
+          </a:prstGeom>
+          <a:solidFill>
+            <a:srgbClr val="404040"/>
+          </a:solidFill>
+          <a:ln>
+            <a:noFill/>
+          </a:ln>
+          <a:effectLst/>
+        </p:spPr>
+        <p:style>
+          <a:lnRef idx="1">
+            <a:schemeClr val="accent1"/>
+          </a:lnRef>
+          <a:fillRef idx="3">
+            <a:schemeClr val="accent1"/>
+          </a:fillRef>
+          <a:effectRef idx="2">
+            <a:schemeClr val="accent1"/>
+          </a:effectRef>
+          <a:fontRef idx="minor">
+            <a:schemeClr val="lt1"/>
+          </a:fontRef>
+        </p:style>
+        <p:txBody>
+          <a:bodyPr rtlCol="0" anchor="ctr" wrap="square" lIns="18288" rIns="18288" tIns="18288" bIns="18288"/>
+          <a:lstStyle/>
+          <a:p>
+            <a:pPr algn="ctr"/>
+            <a:r>
+              <a:rPr sz="1200" b="1" i="0" u="none">
+                <a:solidFill>
+                  <a:srgbClr val="FFFFFF"/>
+                </a:solidFill>
+                <a:latin typeface="맑은 고딕"/>
+                <a:ea typeface="맑은 고딕"/>
+                <a:cs typeface="맑은 고딕"/>
+              </a:rPr>
+              <a:t>현장을 인식하고 움직이는 AI로 무인화·엔터테인먼트 혁신</a:t>
+            </a:r>
+          </a:p>
+        </p:txBody>
+      </p:sp>
+      <p:sp>
+        <p:nvSpPr>
+          <p:cNvPr id="33" name="TextBox 32"/>
           <p:cNvSpPr txBox="1"/>
           <p:nvPr/>
         </p:nvSpPr>
@@ -4279,7 +4498,7 @@
       </p:sp>
       <p:sp>
         <p:nvSpPr>
-          <p:cNvPr id="30" name="Rectangle 29"/>
+          <p:cNvPr id="34" name="Rectangle 33"/>
           <p:cNvSpPr/>
           <p:nvPr/>
         </p:nvSpPr>
@@ -4334,7 +4553,7 @@
       </p:sp>
       <p:sp>
         <p:nvSpPr>
-          <p:cNvPr id="31" name="Oval 30"/>
+          <p:cNvPr id="35" name="Oval 34"/>
           <p:cNvSpPr/>
           <p:nvPr/>
         </p:nvSpPr>
@@ -4391,7 +4610,7 @@
       </p:sp>
       <p:sp>
         <p:nvSpPr>
-          <p:cNvPr id="32" name="Rectangle 31"/>
+          <p:cNvPr id="36" name="Rectangle 35"/>
           <p:cNvSpPr/>
           <p:nvPr/>
         </p:nvSpPr>
@@ -4448,7 +4667,7 @@
       </p:sp>
       <p:sp>
         <p:nvSpPr>
-          <p:cNvPr id="33" name="TextBox 32"/>
+          <p:cNvPr id="37" name="TextBox 36"/>
           <p:cNvSpPr txBox="1"/>
           <p:nvPr/>
         </p:nvSpPr>
@@ -4558,7 +4777,7 @@
       </p:sp>
       <p:sp>
         <p:nvSpPr>
-          <p:cNvPr id="34" name="Rectangle 33"/>
+          <p:cNvPr id="38" name="Rectangle 37"/>
           <p:cNvSpPr/>
           <p:nvPr/>
         </p:nvSpPr>
@@ -4613,7 +4832,7 @@
       </p:sp>
       <p:sp>
         <p:nvSpPr>
-          <p:cNvPr id="35" name="Oval 34"/>
+          <p:cNvPr id="39" name="Oval 38"/>
           <p:cNvSpPr/>
           <p:nvPr/>
         </p:nvSpPr>
@@ -4670,7 +4889,7 @@
       </p:sp>
       <p:sp>
         <p:nvSpPr>
-          <p:cNvPr id="36" name="Rectangle 35"/>
+          <p:cNvPr id="40" name="Rectangle 39"/>
           <p:cNvSpPr/>
           <p:nvPr/>
         </p:nvSpPr>
@@ -4727,7 +4946,7 @@
       </p:sp>
       <p:sp>
         <p:nvSpPr>
-          <p:cNvPr id="37" name="TextBox 36"/>
+          <p:cNvPr id="41" name="TextBox 40"/>
           <p:cNvSpPr txBox="1"/>
           <p:nvPr/>
         </p:nvSpPr>
@@ -4808,7 +5027,7 @@
       </p:sp>
       <p:sp>
         <p:nvSpPr>
-          <p:cNvPr id="38" name="Rectangle 37"/>
+          <p:cNvPr id="42" name="Rectangle 41"/>
           <p:cNvSpPr/>
           <p:nvPr/>
         </p:nvSpPr>
@@ -4863,7 +5082,7 @@
       </p:sp>
       <p:sp>
         <p:nvSpPr>
-          <p:cNvPr id="39" name="Oval 38"/>
+          <p:cNvPr id="43" name="Oval 42"/>
           <p:cNvSpPr/>
           <p:nvPr/>
         </p:nvSpPr>
@@ -4920,7 +5139,7 @@
       </p:sp>
       <p:sp>
         <p:nvSpPr>
-          <p:cNvPr id="40" name="Rectangle 39"/>
+          <p:cNvPr id="44" name="Rectangle 43"/>
           <p:cNvSpPr/>
           <p:nvPr/>
         </p:nvSpPr>
@@ -4977,7 +5196,7 @@
       </p:sp>
       <p:sp>
         <p:nvSpPr>
-          <p:cNvPr id="41" name="TextBox 40"/>
+          <p:cNvPr id="45" name="TextBox 44"/>
           <p:cNvSpPr txBox="1"/>
           <p:nvPr/>
         </p:nvSpPr>
@@ -5087,7 +5306,7 @@
       </p:sp>
       <p:sp>
         <p:nvSpPr>
-          <p:cNvPr id="42" name="TextBox 41"/>
+          <p:cNvPr id="46" name="TextBox 45"/>
           <p:cNvSpPr txBox="1"/>
           <p:nvPr/>
         </p:nvSpPr>
@@ -5124,7 +5343,7 @@
       </p:sp>
       <p:sp>
         <p:nvSpPr>
-          <p:cNvPr id="43" name="Rectangle 42"/>
+          <p:cNvPr id="47" name="Rectangle 46"/>
           <p:cNvSpPr/>
           <p:nvPr/>
         </p:nvSpPr>
@@ -5168,7 +5387,7 @@
       </p:sp>
       <p:sp>
         <p:nvSpPr>
-          <p:cNvPr id="44" name="TextBox 43"/>
+          <p:cNvPr id="48" name="TextBox 47"/>
           <p:cNvSpPr txBox="1"/>
           <p:nvPr/>
         </p:nvSpPr>
@@ -5205,7 +5424,7 @@
       </p:sp>
       <p:sp>
         <p:nvSpPr>
-          <p:cNvPr id="45" name="TextBox 44"/>
+          <p:cNvPr id="49" name="TextBox 48"/>
           <p:cNvSpPr txBox="1"/>
           <p:nvPr/>
         </p:nvSpPr>
@@ -5242,7 +5461,7 @@
       </p:sp>
       <p:sp>
         <p:nvSpPr>
-          <p:cNvPr id="46" name="TextBox 45"/>
+          <p:cNvPr id="50" name="TextBox 49"/>
           <p:cNvSpPr txBox="1"/>
           <p:nvPr/>
         </p:nvSpPr>
@@ -5279,7 +5498,7 @@
       </p:sp>
       <p:sp>
         <p:nvSpPr>
-          <p:cNvPr id="47" name="TextBox 46"/>
+          <p:cNvPr id="51" name="TextBox 50"/>
           <p:cNvSpPr txBox="1"/>
           <p:nvPr/>
         </p:nvSpPr>
@@ -5316,7 +5535,7 @@
       </p:sp>
       <p:sp>
         <p:nvSpPr>
-          <p:cNvPr id="48" name="TextBox 47"/>
+          <p:cNvPr id="52" name="TextBox 51"/>
           <p:cNvSpPr txBox="1"/>
           <p:nvPr/>
         </p:nvSpPr>
@@ -5353,7 +5572,7 @@
       </p:sp>
       <p:sp>
         <p:nvSpPr>
-          <p:cNvPr id="49" name="TextBox 48"/>
+          <p:cNvPr id="53" name="TextBox 52"/>
           <p:cNvSpPr txBox="1"/>
           <p:nvPr/>
         </p:nvSpPr>
@@ -5390,7 +5609,7 @@
       </p:sp>
       <p:sp>
         <p:nvSpPr>
-          <p:cNvPr id="50" name="TextBox 49"/>
+          <p:cNvPr id="54" name="TextBox 53"/>
           <p:cNvSpPr txBox="1"/>
           <p:nvPr/>
         </p:nvSpPr>
@@ -5427,7 +5646,7 @@
       </p:sp>
       <p:sp>
         <p:nvSpPr>
-          <p:cNvPr id="51" name="TextBox 50"/>
+          <p:cNvPr id="55" name="TextBox 54"/>
           <p:cNvSpPr txBox="1"/>
           <p:nvPr/>
         </p:nvSpPr>
@@ -5464,7 +5683,7 @@
       </p:sp>
       <p:sp>
         <p:nvSpPr>
-          <p:cNvPr id="52" name="TextBox 51"/>
+          <p:cNvPr id="56" name="TextBox 55"/>
           <p:cNvSpPr txBox="1"/>
           <p:nvPr/>
         </p:nvSpPr>
@@ -5501,7 +5720,7 @@
       </p:sp>
       <p:sp>
         <p:nvSpPr>
-          <p:cNvPr id="53" name="TextBox 52"/>
+          <p:cNvPr id="57" name="TextBox 56"/>
           <p:cNvSpPr txBox="1"/>
           <p:nvPr/>
         </p:nvSpPr>

</xml_diff>

<commit_message>
Add case dates to theme park AI technology bullets
Co-Authored-By: Claude Opus 5.5 <noreply@anthropic.com>
Claude-Session: https://claude.ai/code/session_014TbtPTXZRwab3hp8YY9eJi
</commit_message>
<xml_diff>
--- a/02_Themepark_AI_Cases.pptx
+++ b/02_Themepark_AI_Cases.pptx
@@ -3583,7 +3583,7 @@
                 <a:ea typeface="맑은 고딕"/>
                 <a:cs typeface="맑은 고딕"/>
               </a:rPr>
-              <a:t>→ 수요 평준화 및 객단가 제고 (Europa-Park, USJ)</a:t>
+              <a:t>→ 수요 평준화 및 객단가 제고 (USJ '19.1 도입, Europa-Park)</a:t>
             </a:r>
           </a:p>
         </p:txBody>
@@ -3991,7 +3991,7 @@
                 <a:ea typeface="맑은 고딕"/>
                 <a:cs typeface="맑은 고딕"/>
               </a:rPr>
-              <a:t>→ 에버랜드, 40년 추억 사진을 AI 영상으로 복원</a:t>
+              <a:t>→ 에버랜드, 40년 추억 사진을 AI 영상으로 복원 ('25.5)</a:t>
             </a:r>
           </a:p>
         </p:txBody>
@@ -4304,7 +4304,7 @@
                 <a:ea typeface="맑은 고딕"/>
                 <a:cs typeface="맑은 고딕"/>
               </a:rPr>
-              <a:t>→ Universal Beijing, Shanghai Disneyland 적용</a:t>
+              <a:t>→ Universal Beijing ('21.9), Shanghai Disneyland ('21.5) 적용</a:t>
             </a:r>
           </a:p>
         </p:txBody>
@@ -4399,7 +4399,7 @@
                 <a:ea typeface="맑은 고딕"/>
                 <a:cs typeface="맑은 고딕"/>
               </a:rPr>
-              <a:t>→ Disney BDX 드로이드, 에버랜드 4족보행 로봇</a:t>
+              <a:t>→ Disney BDX 드로이드 ('23~), 에버랜드 4족보행 로봇 ('25.9)</a:t>
             </a:r>
           </a:p>
         </p:txBody>

</xml_diff>